<commit_message>
Say going to and want to in the Level 4 listening
The recordings use the full forms. The Hear It box still tells learners that people often say gonna and wanna, and that they only need to recognize those short forms.
</commit_message>
<xml_diff>
--- a/level4/slides/Level4_Lesson10_Slides.pptx
+++ b/level4/slides/Level4_Lesson10_Slides.pptx
@@ -1041,12 +1041,12 @@
           <a:lstStyle/>
           <a:p>
             <a:r>
-              <a:t>"Hear it, say it" (3 min): Point to the script line. gonna = going to: "I'm gonna unplug my phone charger." Then practice the stress on the small word: turn it OFF, put it aWAY, and the linking: turn_it_off, take_it_out. The class repeats the two lines twice.</a:t>
-            </a:r>
-          </a:p>
-          <a:p>
-            <a:r>
-              <a:t>Reductions: the listening has gonna. Learners need to understand it; they can always say going to.</a:t>
+              <a:t>"Hear it, say it" (3 min): Point to the script line. gonna = going to: "I'm going to unplug my phone charger." Then practice the stress on the small word: turn it OFF, put it aWAY, and the linking: turn_it_off, take_it_out. The class repeats the two lines twice.</a:t>
+            </a:r>
+          </a:p>
+          <a:p>
+            <a:r>
+              <a:t>Reductions: the listening says going to. People often say gonna. Learners only need to recognize it.</a:t>
             </a:r>
           </a:p>
           <a:p>
@@ -1486,7 +1486,7 @@
           </a:p>
           <a:p>
             <a:r>
-              <a:t>No speaker? Read the script with a volunteer at a natural, friendly speed, two times. Say gonna and wanna where the script has them.</a:t>
+              <a:t>No speaker? Read the script with a volunteer at a natural, friendly speed, two times. The script says going to and want to. People often say gonna and wanna; learners only need to recognize those words.</a:t>
             </a:r>
           </a:p>
           <a:p>
@@ -1541,7 +1541,7 @@
           </a:p>
           <a:p>
             <a:r>
-              <a:t>Hana: Good idea. And I'm gonna unplug my phone charger in the morning. It uses electricity all day.</a:t>
+              <a:t>Hana: Good idea. And I'm going to unplug my phone charger in the morning. It uses electricity all day.</a:t>
             </a:r>
           </a:p>
           <a:p>
@@ -16456,6 +16456,17 @@
               <a:buNone/>
             </a:pPr>
             <a:r>
+              <a:rPr lang="en-US" sz="2000" dirty="0" b="1">
+                <a:solidFill>
+                  <a:srgbClr val="5B3FC4"/>
+                </a:solidFill>
+                <a:latin typeface="Lexend Deca" pitchFamily="34" charset="0"/>
+                <a:ea typeface="Lexend Deca" pitchFamily="34" charset="-122"/>
+                <a:cs typeface="Lexend Deca" pitchFamily="34" charset="-120"/>
+              </a:rPr>
+              <a:t>gonna</a:t>
+            </a:r>
+            <a:r>
               <a:rPr lang="en-US" sz="2000" dirty="0">
                 <a:solidFill>
                   <a:srgbClr val="1B2236"/>
@@ -16464,7 +16475,7 @@
                 <a:ea typeface="Lexend Deca" pitchFamily="34" charset="-122"/>
                 <a:cs typeface="Lexend Deca" pitchFamily="34" charset="-120"/>
               </a:rPr>
-              <a:t>You will hear </a:t>
+              <a:t> is a short form. This listening says </a:t>
             </a:r>
             <a:r>
               <a:rPr lang="en-US" sz="2000" dirty="0" b="1">
@@ -16475,7 +16486,7 @@
                 <a:ea typeface="Lexend Deca" pitchFamily="34" charset="-122"/>
                 <a:cs typeface="Lexend Deca" pitchFamily="34" charset="-120"/>
               </a:rPr>
-              <a:t>gonna</a:t>
+              <a:t>going to</a:t>
             </a:r>
             <a:r>
               <a:rPr lang="en-US" sz="2000" dirty="0">
@@ -16641,7 +16652,7 @@
                 <a:ea typeface="Lexend Deca" pitchFamily="34" charset="-122"/>
                 <a:cs typeface="Lexend Deca" pitchFamily="34" charset="-120"/>
               </a:rPr>
-              <a:t>gonna</a:t>
+              <a:t>going to</a:t>
             </a:r>
             <a:r>
               <a:rPr lang="en-US" sz="1800" dirty="0" b="1">

</xml_diff>

<commit_message>
Publish the Level 4 listening audio on the site.
All 13 gate-PASS files are named in the lesson books, the downloads, and the slides. Lessons 3 and 13 are the last two copies added to the site audio folder.
</commit_message>
<xml_diff>
--- a/level4/slides/Level4_Lesson10_Slides.pptx
+++ b/level4/slides/Level4_Lesson10_Slides.pptx
@@ -536,7 +536,7 @@
           </a:p>
           <a:p>
             <a:r>
-              <a:t>Audio: the listening audio for this lesson (about 2:07) is coming soon. It will use computer-generated voices (Chatterbox TTS cloned from synthetic Kokoro-82M reference clips); no recordings of real people. Until it is ready, read the listening script (in the notes of the Before You Listen slide) with a volunteer. The names and the story are invented.</a:t>
+              <a:t>Audio: synthetic voices, computer-generated (Chatterbox TTS cloned from Kokoro-82M reference clips). No recordings of real people. The names and the story are invented.</a:t>
             </a:r>
           </a:p>
           <a:p>
@@ -1481,7 +1481,7 @@
           </a:p>
           <a:p>
             <a:r>
-              <a:t>The audio (about 2:07) is coming soon. When it is ready, it plays the conversation once; press play again for play 2. Until then, read the listening script (at the end of these notes) with a volunteer.</a:t>
+              <a:t>The audio (L4_L10_listening.mp3, about 2:07) plays the conversation once. Press play again for play 2. A third play is fine if the class needs it.</a:t>
             </a:r>
           </a:p>
           <a:p>
@@ -1491,7 +1491,7 @@
           </a:p>
           <a:p>
             <a:r>
-              <a:t>Audio: the listening audio for this lesson (about 2:07) is coming soon. It will use computer-generated voices (Chatterbox TTS cloned from synthetic Kokoro-82M reference clips); no recordings of real people. Until it is ready, read the listening script (in the notes of the Before You Listen slide) with a volunteer. The names and the story are invented.</a:t>
+              <a:t>Audio: synthetic voices, computer-generated (Chatterbox TTS cloned from Kokoro-82M reference clips). No recordings of real people. The names and the story are invented.</a:t>
             </a:r>
           </a:p>
           <a:p>
@@ -1502,121 +1502,6 @@
           <a:p>
             <a:r>
               <a:t>Picture: Twemoji graphics by Twitter, Inc. and other contributors (https://github.com/jdecked/twemoji), CC BY 4.0 (https://creativecommons.org/licenses/by/4.0/); resized and combined, with signs and labels (images/CREDITS.md).</a:t>
-            </a:r>
-          </a:p>
-          <a:p>
-            <a:r>
-              <a:t>Listening script (the audio is coming soon; until then, read it aloud with a volunteer at a normal, friendly speed):</a:t>
-            </a:r>
-          </a:p>
-          <a:p>
-            <a:r>
-              <a:t>Narrator: Lesson ten. Two roommates, Sofia and Hana, look at their electric bill. Then Sofia calls the electric company.</a:t>
-            </a:r>
-          </a:p>
-          <a:p>
-            <a:r>
-              <a:t>Sofia: Hana, look at this. Our electric bill is one hundred and forty-two dollars this month!</a:t>
-            </a:r>
-          </a:p>
-          <a:p>
-            <a:r>
-              <a:t>Hana: What? Last month it was ninety dollars. Why is it so high?</a:t>
-            </a:r>
-          </a:p>
-          <a:p>
-            <a:r>
-              <a:t>Sofia: Well, we use too much electricity. The heat is on all day, and the lights are on in empty rooms.</a:t>
-            </a:r>
-          </a:p>
-          <a:p>
-            <a:r>
-              <a:t>Hana: You're right. I always forget to turn them off. Oh, the TV is on now, and nobody is watching. I'll turn it off.</a:t>
-            </a:r>
-          </a:p>
-          <a:p>
-            <a:r>
-              <a:t>Sofia: OK, let's make a plan. First, we can turn down the heat at night. Sixty-eight degrees is fine.</a:t>
-            </a:r>
-          </a:p>
-          <a:p>
-            <a:r>
-              <a:t>Hana: Good idea. And I'm going to unplug my phone charger in the morning. It uses electricity all day.</a:t>
-            </a:r>
-          </a:p>
-          <a:p>
-            <a:r>
-              <a:t>Sofia: Also, let's put on sweaters and not turn up the heat. Can you call the electric company? I have class.</a:t>
-            </a:r>
-          </a:p>
-          <a:p>
-            <a:r>
-              <a:t>Hana: Sorry, I have work. Can you call them tonight?</a:t>
-            </a:r>
-          </a:p>
-          <a:p>
-            <a:r>
-              <a:t>Sofia: Sure. I'll call them now.</a:t>
-            </a:r>
-          </a:p>
-          <a:p>
-            <a:r>
-              <a:t>Paul: Thank you for calling City Power. This is Paul. How can I help you?</a:t>
-            </a:r>
-          </a:p>
-          <a:p>
-            <a:r>
-              <a:t>Sofia: Hi. I'm calling about my bill. When is it due?</a:t>
-            </a:r>
-          </a:p>
-          <a:p>
-            <a:r>
-              <a:t>Paul: Can I have your account number, please?</a:t>
-            </a:r>
-          </a:p>
-          <a:p>
-            <a:r>
-              <a:t>Sofia: Yes. It's four, seven, two, one, nine.</a:t>
-            </a:r>
-          </a:p>
-          <a:p>
-            <a:r>
-              <a:t>Paul: Thank you. Your bill is due on March fifteenth.</a:t>
-            </a:r>
-          </a:p>
-          <a:p>
-            <a:r>
-              <a:t>Sofia: OK. Also, do you have any programs to help us save energy?</a:t>
-            </a:r>
-          </a:p>
-          <a:p>
-            <a:r>
-              <a:t>Paul: Yes. We have a free home energy check. Someone visits your apartment and gives you tips. And you can get free light bulbs.</a:t>
-            </a:r>
-          </a:p>
-          <a:p>
-            <a:r>
-              <a:t>Sofia: That sounds great. Can I sign up?</a:t>
-            </a:r>
-          </a:p>
-          <a:p>
-            <a:r>
-              <a:t>Paul: Sure. Is next Tuesday morning OK?</a:t>
-            </a:r>
-          </a:p>
-          <a:p>
-            <a:r>
-              <a:t>Sofia: Yes, that's perfect. Thank you.</a:t>
-            </a:r>
-          </a:p>
-          <a:p>
-            <a:r>
-              <a:t>Paul: You're welcome. And don't forget to turn off the lights when you leave a room!</a:t>
-            </a:r>
-          </a:p>
-          <a:p>
-            <a:r>
-              <a:t>Narrator: That's the end of the listening.</a:t>
             </a:r>
           </a:p>
         </p:txBody>
@@ -12106,7 +11991,7 @@
                 <a:ea typeface="Lexend Deca" pitchFamily="34" charset="-122"/>
                 <a:cs typeface="Lexend Deca" pitchFamily="34" charset="-120"/>
               </a:rPr>
-              <a:t>Audio (about 2:07): coming soon.</a:t>
+              <a:t>Audio: about 2:07. It plays once.</a:t>
             </a:r>
             <a:endParaRPr lang="en-US" sz="2200" dirty="0"/>
           </a:p>
@@ -31048,7 +30933,7 @@
                 <a:ea typeface="Lexend Deca" pitchFamily="34" charset="-122"/>
                 <a:cs typeface="Lexend Deca" pitchFamily="34" charset="-120"/>
               </a:rPr>
-              <a:t>Audio (coming soon): synthetic voices made with Chatterbox TTS (MIT License), cloned from short synthetic reference clips made with Kokoro-82M (Apache License 2.0). No recordings of real people. Each file will carry an inaudible Perth watermark marking it as AI-generated. Font: Lexend Deca (OFL 1.1).</a:t>
+              <a:t>Audio: synthetic voices made with Chatterbox TTS (MIT License), cloned from short synthetic reference clips made with Kokoro-82M (Apache License 2.0). No recordings of real people were used. Each file carries an inaudible Perth watermark marking it as AI-generated. Font: Lexend Deca (OFL 1.1).</a:t>
             </a:r>
             <a:endParaRPr lang="en-US" sz="1350" dirty="0" b="0"/>
           </a:p>

</xml_diff>

<commit_message>
Level 4: add the gonna/wanna everyday-English note to every lesson (#42)
Student Hear it box, teacher Reductions note, and the Hear It slide now say what
gonna and wanna mean, that learners will hear them, and when they are fine to use.
The recordings keep going to / want to. Rebuilt the 13 DOCX/PDF books, decks and
presenter JSON.
</commit_message>
<xml_diff>
--- a/level4/slides/Level4_Lesson10_Slides.pptx
+++ b/level4/slides/Level4_Lesson10_Slides.pptx
@@ -1047,6 +1047,11 @@
           <a:p>
             <a:r>
               <a:t>Reductions: the listening says going to. People often say gonna. Learners only need to recognize it.</a:t>
+            </a:r>
+          </a:p>
+          <a:p>
+            <a:r>
+              <a:t>Everyday English: people often say gonna (going to) and wanna (want to). Learners will hear them often. They are fine in casual talk; in writing, at a job interview, or in a formal email, use going to and want to. The listening uses the full forms.</a:t>
             </a:r>
           </a:p>
           <a:p>
@@ -16360,7 +16365,7 @@
                 <a:ea typeface="Lexend Deca" pitchFamily="34" charset="-122"/>
                 <a:cs typeface="Lexend Deca" pitchFamily="34" charset="-120"/>
               </a:rPr>
-              <a:t> is a short form. This listening says </a:t>
+              <a:t> = going to, </a:t>
             </a:r>
             <a:r>
               <a:rPr lang="en-US" sz="2000" dirty="0" b="1">
@@ -16371,7 +16376,7 @@
                 <a:ea typeface="Lexend Deca" pitchFamily="34" charset="-122"/>
                 <a:cs typeface="Lexend Deca" pitchFamily="34" charset="-120"/>
               </a:rPr>
-              <a:t>going to</a:t>
+              <a:t>wanna</a:t>
             </a:r>
             <a:r>
               <a:rPr lang="en-US" sz="2000" dirty="0">
@@ -16382,7 +16387,7 @@
                 <a:ea typeface="Lexend Deca" pitchFamily="34" charset="-122"/>
                 <a:cs typeface="Lexend Deca" pitchFamily="34" charset="-120"/>
               </a:rPr>
-              <a:t>.</a:t>
+              <a:t> = want to: fine in everyday talk.</a:t>
             </a:r>
             <a:endParaRPr lang="en-US" sz="2000" dirty="0"/>
           </a:p>

</xml_diff>